<commit_message>
chore: rimuovi Atzori, aggiungi README per la consegna
- Atzori non fa più parte del gruppo: rimosso da src/App.tsx (titolo,
  vittoria, easter egg) e dalla presentazione PPTX, dove le domande 8-10
  sono state redistribuite tra Loche e Cotza (ora 2 card invece di 3)
- aggiunto README.md con link al gioco live, alla presentazione e alle
  istruzioni di sviluppo, per la consegna della repo al professore

Co-Authored-By: Claude Sonnet 5 <noreply@anthropic.com>
Claude-Session: https://claude.ai/code/session_01V1rX1Z2gukAwunwcwb83FW
</commit_message>
<xml_diff>
--- a/Presentazione-Gruppo3.pptx
+++ b/Presentazione-Gruppo3.pptx
@@ -122,12 +122,12 @@
   <p:extLst>
     <p:ext uri="{521415D9-36F7-43E2-AB2F-B90AF26B5E84}">
       <p14:sectionLst xmlns:p14="http://schemas.microsoft.com/office/powerpoint/2010/main">
-        <p14:section name="Apertura" id="{6c92b8b6-5705-c4a4-e569-8336357ad1f7}">
+        <p14:section name="Apertura" id="{1a347c29-0d87-cc3d-ad54-e689cfb7710d}">
           <p14:sldIdLst>
             <p14:sldId id="256"/>
           </p14:sldIdLst>
         </p14:section>
-        <p14:section name="Teoria" id="{df4a6f56-1e2d-a057-55ee-7f19267cd470}">
+        <p14:section name="Teoria" id="{f4e3daa7-30c6-f50c-554a-883e6fa1098f}">
           <p14:sldIdLst>
             <p14:sldId id="257"/>
             <p14:sldId id="258"/>
@@ -139,7 +139,7 @@
             <p14:sldId id="264"/>
           </p14:sldIdLst>
         </p14:section>
-        <p14:section name="Conversioni" id="{aee2f581-0a7c-ecb1-a239-b16db54be4e3}">
+        <p14:section name="Conversioni" id="{09a21313-e6a7-5a7b-3f69-d6e0f3fe6fb2}">
           <p14:sldIdLst>
             <p14:sldId id="265"/>
             <p14:sldId id="266"/>
@@ -148,7 +148,7 @@
             <p14:sldId id="269"/>
           </p14:sldIdLst>
         </p14:section>
-        <p14:section name="Chiusura" id="{7c05de47-2ca5-efe5-7507-8f2d7409804e}">
+        <p14:section name="Chiusura" id="{c15bd547-388b-9f5b-6d98-f47ab68c5436}">
           <p14:sldIdLst>
             <p14:sldId id="270"/>
             <p14:sldId id="271"/>
@@ -2757,7 +2757,7 @@
                 <a:ea typeface="Courier New" pitchFamily="34" charset="-122"/>
                 <a:cs typeface="Courier New" pitchFamily="34" charset="-120"/>
               </a:rPr>
-              <a:t>GRUPPO 3:  LOCHE  •  COTZA  •  ATZORI</a:t>
+              <a:t>GRUPPO 3:  LOCHE  •  COTZA</a:t>
             </a:r>
             <a:endParaRPr lang="en-US" sz="1800" dirty="0"/>
           </a:p>
@@ -7059,7 +7059,7 @@
                 <a:ea typeface="Calibri" pitchFamily="34" charset="-122"/>
                 <a:cs typeface="Calibri" pitchFamily="34" charset="-120"/>
               </a:rPr>
-              <a:t>Gruppo 3: Loche • Cotza • Atzori   |   Prof. Concu   |   A.S. 2026/2027</a:t>
+              <a:t>Gruppo 3: Loche • Cotza   |   Prof. Concu   |   A.S. 2026/2027</a:t>
             </a:r>
             <a:endParaRPr lang="en-US" sz="1400" dirty="0"/>
           </a:p>
@@ -7139,8 +7139,8 @@
         </p:nvSpPr>
         <p:spPr>
           <a:xfrm>
-            <a:off x="457200" y="1371600"/>
-            <a:ext cx="2651760" cy="3017520"/>
+            <a:off x="1188720" y="1371600"/>
+            <a:ext cx="3291840" cy="3017520"/>
           </a:xfrm>
           <a:prstGeom prst="rect">
             <a:avLst/>
@@ -7164,8 +7164,8 @@
         </p:nvSpPr>
         <p:spPr>
           <a:xfrm>
-            <a:off x="640080" y="1554480"/>
-            <a:ext cx="2286000" cy="365760"/>
+            <a:off x="1417320" y="1554480"/>
+            <a:ext cx="2834640" cy="365760"/>
           </a:xfrm>
           <a:prstGeom prst="rect">
             <a:avLst/>
@@ -7203,8 +7203,8 @@
         </p:nvSpPr>
         <p:spPr>
           <a:xfrm>
-            <a:off x="640080" y="2057400"/>
-            <a:ext cx="2286000" cy="320040"/>
+            <a:off x="1417320" y="2057400"/>
+            <a:ext cx="2834640" cy="320040"/>
           </a:xfrm>
           <a:prstGeom prst="rect">
             <a:avLst/>
@@ -7228,7 +7228,7 @@
                 <a:ea typeface="Calibri" pitchFamily="34" charset="-122"/>
                 <a:cs typeface="Calibri" pitchFamily="34" charset="-120"/>
               </a:rPr>
-              <a:t>Domande 1-3</a:t>
+              <a:t>Domande 1-5</a:t>
             </a:r>
             <a:endParaRPr lang="en-US" sz="1600" dirty="0"/>
           </a:p>
@@ -7242,8 +7242,8 @@
         </p:nvSpPr>
         <p:spPr>
           <a:xfrm>
-            <a:off x="640080" y="2514600"/>
-            <a:ext cx="2286000" cy="1188720"/>
+            <a:off x="1417320" y="2514600"/>
+            <a:ext cx="2834640" cy="1188720"/>
           </a:xfrm>
           <a:prstGeom prst="rect">
             <a:avLst/>
@@ -7267,7 +7267,7 @@
                 <a:ea typeface="Calibri" pitchFamily="34" charset="-122"/>
                 <a:cs typeface="Calibri" pitchFamily="34" charset="-120"/>
               </a:rPr>
-              <a:t>Analogico e digitale, perché il digitale, codifica binaria</a:t>
+              <a:t>Analogico e digitale, perché il digitale, codifica binaria, sistema di numerazione, sistemi esistenti</a:t>
             </a:r>
             <a:endParaRPr lang="en-US" sz="1400" dirty="0"/>
           </a:p>
@@ -7281,8 +7281,8 @@
         </p:nvSpPr>
         <p:spPr>
           <a:xfrm>
-            <a:off x="640080" y="3840480"/>
-            <a:ext cx="2286000" cy="365760"/>
+            <a:off x="1417320" y="3840480"/>
+            <a:ext cx="2834640" cy="365760"/>
           </a:xfrm>
           <a:prstGeom prst="rect">
             <a:avLst/>
@@ -7306,7 +7306,7 @@
                 <a:ea typeface="Courier New" pitchFamily="34" charset="-122"/>
                 <a:cs typeface="Courier New" pitchFamily="34" charset="-120"/>
               </a:rPr>
-              <a:t>4 min</a:t>
+              <a:t>7 min</a:t>
             </a:r>
             <a:endParaRPr lang="en-US" sz="1800" dirty="0"/>
           </a:p>
@@ -7320,8 +7320,8 @@
         </p:nvSpPr>
         <p:spPr>
           <a:xfrm>
-            <a:off x="3291840" y="1371600"/>
-            <a:ext cx="2651760" cy="3017520"/>
+            <a:off x="4937760" y="1371600"/>
+            <a:ext cx="3291840" cy="3017520"/>
           </a:xfrm>
           <a:prstGeom prst="rect">
             <a:avLst/>
@@ -7345,8 +7345,8 @@
         </p:nvSpPr>
         <p:spPr>
           <a:xfrm>
-            <a:off x="3474720" y="1554480"/>
-            <a:ext cx="2286000" cy="365760"/>
+            <a:off x="5166360" y="1554480"/>
+            <a:ext cx="2834640" cy="365760"/>
           </a:xfrm>
           <a:prstGeom prst="rect">
             <a:avLst/>
@@ -7384,8 +7384,8 @@
         </p:nvSpPr>
         <p:spPr>
           <a:xfrm>
-            <a:off x="3474720" y="2057400"/>
-            <a:ext cx="2286000" cy="320040"/>
+            <a:off x="5166360" y="2057400"/>
+            <a:ext cx="2834640" cy="320040"/>
           </a:xfrm>
           <a:prstGeom prst="rect">
             <a:avLst/>
@@ -7409,7 +7409,7 @@
                 <a:ea typeface="Calibri" pitchFamily="34" charset="-122"/>
                 <a:cs typeface="Calibri" pitchFamily="34" charset="-120"/>
               </a:rPr>
-              <a:t>Domande 4-7</a:t>
+              <a:t>Domande 6-10</a:t>
             </a:r>
             <a:endParaRPr lang="en-US" sz="1600" dirty="0"/>
           </a:p>
@@ -7423,8 +7423,8 @@
         </p:nvSpPr>
         <p:spPr>
           <a:xfrm>
-            <a:off x="3474720" y="2514600"/>
-            <a:ext cx="2286000" cy="1188720"/>
+            <a:off x="5166360" y="2514600"/>
+            <a:ext cx="2834640" cy="1188720"/>
           </a:xfrm>
           <a:prstGeom prst="rect">
             <a:avLst/>
@@ -7448,7 +7448,7 @@
                 <a:ea typeface="Calibri" pitchFamily="34" charset="-122"/>
                 <a:cs typeface="Calibri" pitchFamily="34" charset="-120"/>
               </a:rPr>
-              <a:t>Sistemi di numerazione, tipi di conversione</a:t>
+              <a:t>Conversione e tipi, perché codificare, conversioni assegnate, esempi</a:t>
             </a:r>
             <a:endParaRPr lang="en-US" sz="1400" dirty="0"/>
           </a:p>
@@ -7462,8 +7462,8 @@
         </p:nvSpPr>
         <p:spPr>
           <a:xfrm>
-            <a:off x="3474720" y="3840480"/>
-            <a:ext cx="2286000" cy="365760"/>
+            <a:off x="5166360" y="3840480"/>
+            <a:ext cx="2834640" cy="365760"/>
           </a:xfrm>
           <a:prstGeom prst="rect">
             <a:avLst/>
@@ -7487,188 +7487,7 @@
                 <a:ea typeface="Courier New" pitchFamily="34" charset="-122"/>
                 <a:cs typeface="Courier New" pitchFamily="34" charset="-120"/>
               </a:rPr>
-              <a:t>4 min</a:t>
-            </a:r>
-            <a:endParaRPr lang="en-US" sz="1800" dirty="0"/>
-          </a:p>
-        </p:txBody>
-      </p:sp>
-      <p:sp>
-        <p:nvSpPr>
-          <p:cNvPr id="13" name="Card ATZORI"/>
-          <p:cNvSpPr/>
-          <p:nvPr/>
-        </p:nvSpPr>
-        <p:spPr>
-          <a:xfrm>
-            <a:off x="6126480" y="1371600"/>
-            <a:ext cx="2651760" cy="3017520"/>
-          </a:xfrm>
-          <a:prstGeom prst="rect">
-            <a:avLst/>
-          </a:prstGeom>
-          <a:solidFill>
-            <a:schemeClr val="tx2"/>
-          </a:solidFill>
-          <a:ln w="25400">
-            <a:solidFill>
-              <a:schemeClr val="accent1"/>
-            </a:solidFill>
-            <a:prstDash val="solid"/>
-          </a:ln>
-        </p:spPr>
-      </p:sp>
-      <p:sp>
-        <p:nvSpPr>
-          <p:cNvPr id="14" name="Text 12"/>
-          <p:cNvSpPr txBox="1"/>
-          <p:nvPr/>
-        </p:nvSpPr>
-        <p:spPr>
-          <a:xfrm>
-            <a:off x="6309360" y="1554480"/>
-            <a:ext cx="2286000" cy="365760"/>
-          </a:xfrm>
-          <a:prstGeom prst="rect">
-            <a:avLst/>
-          </a:prstGeom>
-          <a:noFill/>
-          <a:ln/>
-        </p:spPr>
-        <p:txBody>
-          <a:bodyPr wrap="square" lIns="0" tIns="0" rIns="0" bIns="0" rtlCol="0" anchor="t"/>
-          <a:lstStyle/>
-          <a:p>
-            <a:pPr indent="0" marL="0">
-              <a:buNone/>
-            </a:pPr>
-            <a:r>
-              <a:rPr lang="en-US" sz="2200" b="1" dirty="0">
-                <a:solidFill>
-                  <a:schemeClr val="accent1"/>
-                </a:solidFill>
-                <a:latin typeface="Courier New" pitchFamily="34" charset="0"/>
-                <a:ea typeface="Courier New" pitchFamily="34" charset="-122"/>
-                <a:cs typeface="Courier New" pitchFamily="34" charset="-120"/>
-              </a:rPr>
-              <a:t>ATZORI</a:t>
-            </a:r>
-            <a:endParaRPr lang="en-US" sz="2200" dirty="0"/>
-          </a:p>
-        </p:txBody>
-      </p:sp>
-      <p:sp>
-        <p:nvSpPr>
-          <p:cNvPr id="15" name="Text 13"/>
-          <p:cNvSpPr txBox="1"/>
-          <p:nvPr/>
-        </p:nvSpPr>
-        <p:spPr>
-          <a:xfrm>
-            <a:off x="6309360" y="2057400"/>
-            <a:ext cx="2286000" cy="320040"/>
-          </a:xfrm>
-          <a:prstGeom prst="rect">
-            <a:avLst/>
-          </a:prstGeom>
-          <a:noFill/>
-          <a:ln/>
-        </p:spPr>
-        <p:txBody>
-          <a:bodyPr wrap="square" lIns="0" tIns="0" rIns="0" bIns="0" rtlCol="0" anchor="t"/>
-          <a:lstStyle/>
-          <a:p>
-            <a:pPr indent="0" marL="0">
-              <a:buNone/>
-            </a:pPr>
-            <a:r>
-              <a:rPr lang="en-US" sz="1600" b="1" dirty="0">
-                <a:solidFill>
-                  <a:schemeClr val="bg1"/>
-                </a:solidFill>
-                <a:latin typeface="Calibri" pitchFamily="34" charset="0"/>
-                <a:ea typeface="Calibri" pitchFamily="34" charset="-122"/>
-                <a:cs typeface="Calibri" pitchFamily="34" charset="-120"/>
-              </a:rPr>
-              <a:t>Domande 8-10</a:t>
-            </a:r>
-            <a:endParaRPr lang="en-US" sz="1600" dirty="0"/>
-          </a:p>
-        </p:txBody>
-      </p:sp>
-      <p:sp>
-        <p:nvSpPr>
-          <p:cNvPr id="16" name="Text 14"/>
-          <p:cNvSpPr txBox="1"/>
-          <p:nvPr/>
-        </p:nvSpPr>
-        <p:spPr>
-          <a:xfrm>
-            <a:off x="6309360" y="2514600"/>
-            <a:ext cx="2286000" cy="1188720"/>
-          </a:xfrm>
-          <a:prstGeom prst="rect">
-            <a:avLst/>
-          </a:prstGeom>
-          <a:noFill/>
-          <a:ln/>
-        </p:spPr>
-        <p:txBody>
-          <a:bodyPr wrap="square" lIns="0" tIns="0" rIns="0" bIns="0" rtlCol="0" anchor="t"/>
-          <a:lstStyle/>
-          <a:p>
-            <a:pPr indent="0" marL="0">
-              <a:buNone/>
-            </a:pPr>
-            <a:r>
-              <a:rPr lang="en-US" sz="1400" dirty="0">
-                <a:solidFill>
-                  <a:schemeClr val="bg2"/>
-                </a:solidFill>
-                <a:latin typeface="Calibri" pitchFamily="34" charset="0"/>
-                <a:ea typeface="Calibri" pitchFamily="34" charset="-122"/>
-                <a:cs typeface="Calibri" pitchFamily="34" charset="-120"/>
-              </a:rPr>
-              <a:t>Perché codificare, conversioni assegnate, esempi</a:t>
-            </a:r>
-            <a:endParaRPr lang="en-US" sz="1400" dirty="0"/>
-          </a:p>
-        </p:txBody>
-      </p:sp>
-      <p:sp>
-        <p:nvSpPr>
-          <p:cNvPr id="17" name="Text 15"/>
-          <p:cNvSpPr txBox="1"/>
-          <p:nvPr/>
-        </p:nvSpPr>
-        <p:spPr>
-          <a:xfrm>
-            <a:off x="6309360" y="3840480"/>
-            <a:ext cx="2286000" cy="365760"/>
-          </a:xfrm>
-          <a:prstGeom prst="rect">
-            <a:avLst/>
-          </a:prstGeom>
-          <a:noFill/>
-          <a:ln/>
-        </p:spPr>
-        <p:txBody>
-          <a:bodyPr wrap="square" lIns="0" tIns="0" rIns="0" bIns="0" rtlCol="0" anchor="t"/>
-          <a:lstStyle/>
-          <a:p>
-            <a:pPr indent="0" marL="0">
-              <a:buNone/>
-            </a:pPr>
-            <a:r>
-              <a:rPr lang="en-US" sz="1800" b="1" dirty="0">
-                <a:solidFill>
-                  <a:schemeClr val="accent1"/>
-                </a:solidFill>
-                <a:latin typeface="Courier New" pitchFamily="34" charset="0"/>
-                <a:ea typeface="Courier New" pitchFamily="34" charset="-122"/>
-                <a:cs typeface="Courier New" pitchFamily="34" charset="-120"/>
-              </a:rPr>
-              <a:t>5 min</a:t>
+              <a:t>6 min</a:t>
             </a:r>
             <a:endParaRPr lang="en-US" sz="1800" dirty="0"/>
           </a:p>

</xml_diff>